<commit_message>
Release 1.4.0: toolbar buttons keep their place
- Colours moved out of the toolbar: a dot on pen, highlighter and laser
  shows the colour; a tap on the selected tool opens its colours below
- Fixed-width slide counter
- Laser colour can be picked from the laser button
- Guide decks: tools slide says how to choose a colour

Co-Authored-By: Claude Opus 5.5 <noreply@anthropic.com>
Claude-Session: https://claude.ai/code/session_01V4q6MUNQzbvGfyJNvW5Le1
</commit_message>
<xml_diff>
--- a/source/guide-deck-viewer.pptx
+++ b/source/guide-deck-viewer.pptx
@@ -12167,7 +12167,7 @@
                   <a:srgbClr val="555B6B"/>
                 </a:solidFill>
               </a:rPr>
-              <a:t>Pressure-sensitive ink, up to 10 UZH colours.</a:t>
+              <a:t>Pressure-sensitive ink. Tap again for the colours.</a:t>
             </a:r>
           </a:p>
         </p:txBody>
@@ -12550,7 +12550,7 @@
                   <a:srgbClr val="555B6B"/>
                 </a:solidFill>
               </a:rPr>
-              <a:t>Transparent marks in the six UZH accent colours.</a:t>
+              <a:t>Transparent marks. Tap again for the colours.</a:t>
             </a:r>
           </a:p>
         </p:txBody>

</xml_diff>